<commit_message>
docs: complete phase 18 portfolio release evidence
</commit_message>
<xml_diff>
--- a/docs/portfolio/AI-Emergency-Response-Portfolio-Deck.pptx
+++ b/docs/portfolio/AI-Emergency-Response-Portfolio-Deck.pptx
@@ -2,18 +2,18 @@
 <file path=ppt/presentation.xml><?xml version="1.0" encoding="utf-8"?>
 <p:presentation xmlns:p="http://schemas.openxmlformats.org/presentationml/2006/main">
   <p:sldMasterIdLst>
-    <p:sldMasterId xmlns:r="http://schemas.openxmlformats.org/officeDocument/2006/relationships" id="2147483648" r:id="Rdc43138b0feb4a12"/>
+    <p:sldMasterId xmlns:r="http://schemas.openxmlformats.org/officeDocument/2006/relationships" id="2147483648" r:id="R1732c32962cd4ba3"/>
   </p:sldMasterIdLst>
   <p:notesMasterIdLst>
-    <p:notesMasterId xmlns:r="http://schemas.openxmlformats.org/officeDocument/2006/relationships" r:id="Rbf90043922f54994"/>
+    <p:notesMasterId xmlns:r="http://schemas.openxmlformats.org/officeDocument/2006/relationships" r:id="R6f3651d9d01c421b"/>
   </p:notesMasterIdLst>
   <p:sldIdLst>
-    <p:sldId xmlns:r="http://schemas.openxmlformats.org/officeDocument/2006/relationships" id="256" r:id="R73de42d129dc4596"/>
-    <p:sldId xmlns:r="http://schemas.openxmlformats.org/officeDocument/2006/relationships" id="257" r:id="R64744968246444d2"/>
-    <p:sldId xmlns:r="http://schemas.openxmlformats.org/officeDocument/2006/relationships" id="258" r:id="R5332397a75214928"/>
-    <p:sldId xmlns:r="http://schemas.openxmlformats.org/officeDocument/2006/relationships" id="259" r:id="Rca2650aa3b2142f1"/>
-    <p:sldId xmlns:r="http://schemas.openxmlformats.org/officeDocument/2006/relationships" id="260" r:id="R69c36b6dd828463d"/>
-    <p:sldId xmlns:r="http://schemas.openxmlformats.org/officeDocument/2006/relationships" id="261" r:id="R0dff8d938cd14002"/>
+    <p:sldId xmlns:r="http://schemas.openxmlformats.org/officeDocument/2006/relationships" id="256" r:id="R0e4ef9646ff44ad9"/>
+    <p:sldId xmlns:r="http://schemas.openxmlformats.org/officeDocument/2006/relationships" id="257" r:id="R0b5f8c86e2b940a2"/>
+    <p:sldId xmlns:r="http://schemas.openxmlformats.org/officeDocument/2006/relationships" id="258" r:id="Ra3c42edc8953421c"/>
+    <p:sldId xmlns:r="http://schemas.openxmlformats.org/officeDocument/2006/relationships" id="259" r:id="Rbfb1d1fd4f1a448b"/>
+    <p:sldId xmlns:r="http://schemas.openxmlformats.org/officeDocument/2006/relationships" id="260" r:id="Rbe54b11d39cb4b33"/>
+    <p:sldId xmlns:r="http://schemas.openxmlformats.org/officeDocument/2006/relationships" id="261" r:id="R95e403798fb4424c"/>
   </p:sldIdLst>
   <p:sldSz cx="12192000" cy="6858000"/>
   <p:notesSz cx="6858000" cy="9144000"/>
@@ -587,7 +587,7 @@
           <a:lstStyle xmlns:a="http://schemas.openxmlformats.org/drawingml/2006/main"/>
           <a:p xmlns:a="http://schemas.openxmlformats.org/drawingml/2006/main">
             <a:r>
-              <a:t>This is a genuine image from docs/portfolio/screenshots/live-map.png, supplied and indexed from a local Chrome session on 2026-10-15. It predates UI changes in Parts 2.3.4–2.3.5. It shows map tiles/layers and six synthetic incidents/resources, but not selected-report drawer behavior, layer toggling, a complete attribution area, or reconnect. It is limited historical evidence, not a current final-state screenshot. Source: docs/portfolio/screenshots/README.md.</a:t>
+              <a:t>This is the owner's local dashboard capture from 2026-10-18 (docs/portfolio/screenshots/dashboard-2026-10-18.png). It visibly shows 12 active/unassigned reports, eight critical incidents, six open escalation alerts, and eight unread alerts. The source commit and dataset identity are unknown; do not present the shown counts as DEMO18 or responsive acceptance evidence. The screenshot index records the limitations and unresolved UI states.</a:t>
             </a:r>
           </a:p>
         </p:txBody>
@@ -797,7 +797,7 @@
           <a:lstStyle xmlns:a="http://schemas.openxmlformats.org/drawingml/2006/main"/>
           <a:p xmlns:a="http://schemas.openxmlformats.org/drawingml/2006/main">
             <a:r>
-              <a:t>The checks are from the actual 2026-10-17 Phase 2.3.6 run; they do not prove UI rendering, provider quality, performance at scale, or production readiness. The user has since supplied a local Development startup error: SQL Server reports missing DataClassification at AdminSeeder. Migration 20261008095318_AddDataClassification exists, but the configured DB/history was not inspected and no migration was applied. Verify the exact target before applying reviewed pending migrations. Azure deployment is out of scope. Sources: docs/portfolio/ui-ux-verification.md; docs/portfolio/feature-verification.md; docs/portfolio/demo-script.md.</a:t>
+              <a:t>The passing build and tests are the 2026-10-17 baseline and predate later API startup, SignalR logging, and Copilot memory edits. Current screenshots provide limited desktop evidence only; resource loading, active situations, Copilot answer, responsive behavior, and the full walkthrough remain pending. The 2026-10-18 Copilot exception was caused by attaching a second tracked CopilotConversation. A tracked-query fix and SQLite regression test are in the worktree, but the focused build/test attempt failed before compilation during .NET project-reference/workload SDK resolution; do not claim the fix verified. Development startup migration behavior still requires confirming the selected local database. Azure deployment is out of scope. Sources: docs/portfolio/ui-ux-verification.md; docs/portfolio/feature-verification.md; docs/portfolio/screenshots/README.md.</a:t>
             </a:r>
           </a:p>
         </p:txBody>
@@ -895,6 +895,7 @@
                 <a:spcPts val="0"/>
               </a:spcAft>
               <a:buNone/>
+              <a:defRPr/>
             </a:lvl1pPr>
             <a:lvl2pPr marL="0" indent="0">
               <a:lnSpc>
@@ -907,6 +908,7 @@
                 <a:spcPts val="0"/>
               </a:spcAft>
               <a:buNone/>
+              <a:defRPr/>
             </a:lvl2pPr>
             <a:lvl3pPr marL="0" indent="0">
               <a:lnSpc>
@@ -919,6 +921,7 @@
                 <a:spcPts val="0"/>
               </a:spcAft>
               <a:buNone/>
+              <a:defRPr/>
             </a:lvl3pPr>
             <a:lvl4pPr marL="0" indent="0">
               <a:lnSpc>
@@ -931,6 +934,7 @@
                 <a:spcPts val="0"/>
               </a:spcAft>
               <a:buNone/>
+              <a:defRPr/>
             </a:lvl4pPr>
             <a:lvl5pPr marL="0" indent="0">
               <a:lnSpc>
@@ -943,6 +947,7 @@
                 <a:spcPts val="0"/>
               </a:spcAft>
               <a:buNone/>
+              <a:defRPr/>
             </a:lvl5pPr>
             <a:lvl6pPr marL="0" indent="0">
               <a:lnSpc>
@@ -955,6 +960,7 @@
                 <a:spcPts val="0"/>
               </a:spcAft>
               <a:buNone/>
+              <a:defRPr/>
             </a:lvl6pPr>
             <a:lvl7pPr marL="0" indent="0">
               <a:lnSpc>
@@ -967,6 +973,7 @@
                 <a:spcPts val="0"/>
               </a:spcAft>
               <a:buNone/>
+              <a:defRPr/>
             </a:lvl7pPr>
             <a:lvl8pPr marL="0" indent="0">
               <a:lnSpc>
@@ -979,6 +986,7 @@
                 <a:spcPts val="0"/>
               </a:spcAft>
               <a:buNone/>
+              <a:defRPr/>
             </a:lvl8pPr>
             <a:lvl9pPr marL="0" indent="0">
               <a:lnSpc>
@@ -991,6 +999,7 @@
                 <a:spcPts val="0"/>
               </a:spcAft>
               <a:buNone/>
+              <a:defRPr/>
             </a:lvl9pPr>
           </a:lstStyle>
           <a:p xmlns:a="http://schemas.openxmlformats.org/drawingml/2006/main"/>
@@ -1052,6 +1061,7 @@
                 <a:spcPts val="0"/>
               </a:spcAft>
               <a:buNone/>
+              <a:defRPr/>
             </a:lvl1pPr>
             <a:lvl2pPr marL="0" indent="0">
               <a:lnSpc>
@@ -1064,6 +1074,7 @@
                 <a:spcPts val="0"/>
               </a:spcAft>
               <a:buNone/>
+              <a:defRPr/>
             </a:lvl2pPr>
             <a:lvl3pPr marL="0" indent="0">
               <a:lnSpc>
@@ -1076,6 +1087,7 @@
                 <a:spcPts val="0"/>
               </a:spcAft>
               <a:buNone/>
+              <a:defRPr/>
             </a:lvl3pPr>
             <a:lvl4pPr marL="0" indent="0">
               <a:lnSpc>
@@ -1088,6 +1100,7 @@
                 <a:spcPts val="0"/>
               </a:spcAft>
               <a:buNone/>
+              <a:defRPr/>
             </a:lvl4pPr>
             <a:lvl5pPr marL="0" indent="0">
               <a:lnSpc>
@@ -1100,6 +1113,7 @@
                 <a:spcPts val="0"/>
               </a:spcAft>
               <a:buNone/>
+              <a:defRPr/>
             </a:lvl5pPr>
             <a:lvl6pPr marL="0" indent="0">
               <a:lnSpc>
@@ -1112,6 +1126,7 @@
                 <a:spcPts val="0"/>
               </a:spcAft>
               <a:buNone/>
+              <a:defRPr/>
             </a:lvl6pPr>
             <a:lvl7pPr marL="0" indent="0">
               <a:lnSpc>
@@ -1124,6 +1139,7 @@
                 <a:spcPts val="0"/>
               </a:spcAft>
               <a:buNone/>
+              <a:defRPr/>
             </a:lvl7pPr>
             <a:lvl8pPr marL="0" indent="0">
               <a:lnSpc>
@@ -1136,6 +1152,7 @@
                 <a:spcPts val="0"/>
               </a:spcAft>
               <a:buNone/>
+              <a:defRPr/>
             </a:lvl8pPr>
             <a:lvl9pPr marL="0" indent="0">
               <a:lnSpc>
@@ -1148,6 +1165,7 @@
                 <a:spcPts val="0"/>
               </a:spcAft>
               <a:buNone/>
+              <a:defRPr/>
             </a:lvl9pPr>
           </a:lstStyle>
           <a:p xmlns:a="http://schemas.openxmlformats.org/drawingml/2006/main"/>
@@ -1226,6 +1244,7 @@
                 <a:spcPts val="0"/>
               </a:spcAft>
               <a:buNone/>
+              <a:defRPr/>
             </a:lvl1pPr>
             <a:lvl2pPr marL="0" indent="0">
               <a:lnSpc>
@@ -1238,6 +1257,7 @@
                 <a:spcPts val="0"/>
               </a:spcAft>
               <a:buNone/>
+              <a:defRPr/>
             </a:lvl2pPr>
             <a:lvl3pPr marL="0" indent="0">
               <a:lnSpc>
@@ -1250,6 +1270,7 @@
                 <a:spcPts val="0"/>
               </a:spcAft>
               <a:buNone/>
+              <a:defRPr/>
             </a:lvl3pPr>
             <a:lvl4pPr marL="0" indent="0">
               <a:lnSpc>
@@ -1262,6 +1283,7 @@
                 <a:spcPts val="0"/>
               </a:spcAft>
               <a:buNone/>
+              <a:defRPr/>
             </a:lvl4pPr>
             <a:lvl5pPr marL="0" indent="0">
               <a:lnSpc>
@@ -1274,6 +1296,7 @@
                 <a:spcPts val="0"/>
               </a:spcAft>
               <a:buNone/>
+              <a:defRPr/>
             </a:lvl5pPr>
             <a:lvl6pPr marL="0" indent="0">
               <a:lnSpc>
@@ -1286,6 +1309,7 @@
                 <a:spcPts val="0"/>
               </a:spcAft>
               <a:buNone/>
+              <a:defRPr/>
             </a:lvl6pPr>
             <a:lvl7pPr marL="0" indent="0">
               <a:lnSpc>
@@ -1298,6 +1322,7 @@
                 <a:spcPts val="0"/>
               </a:spcAft>
               <a:buNone/>
+              <a:defRPr/>
             </a:lvl7pPr>
             <a:lvl8pPr marL="0" indent="0">
               <a:lnSpc>
@@ -1310,6 +1335,7 @@
                 <a:spcPts val="0"/>
               </a:spcAft>
               <a:buNone/>
+              <a:defRPr/>
             </a:lvl8pPr>
             <a:lvl9pPr marL="0" indent="0">
               <a:lnSpc>
@@ -1322,6 +1348,7 @@
                 <a:spcPts val="0"/>
               </a:spcAft>
               <a:buNone/>
+              <a:defRPr/>
             </a:lvl9pPr>
           </a:lstStyle>
           <a:p xmlns:a="http://schemas.openxmlformats.org/drawingml/2006/main"/>
@@ -1400,6 +1427,7 @@
                 <a:spcPts val="0"/>
               </a:spcAft>
               <a:buNone/>
+              <a:defRPr/>
             </a:lvl1pPr>
             <a:lvl2pPr marL="0" indent="0">
               <a:lnSpc>
@@ -1412,6 +1440,7 @@
                 <a:spcPts val="0"/>
               </a:spcAft>
               <a:buNone/>
+              <a:defRPr/>
             </a:lvl2pPr>
             <a:lvl3pPr marL="0" indent="0">
               <a:lnSpc>
@@ -1424,6 +1453,7 @@
                 <a:spcPts val="0"/>
               </a:spcAft>
               <a:buNone/>
+              <a:defRPr/>
             </a:lvl3pPr>
             <a:lvl4pPr marL="0" indent="0">
               <a:lnSpc>
@@ -1436,6 +1466,7 @@
                 <a:spcPts val="0"/>
               </a:spcAft>
               <a:buNone/>
+              <a:defRPr/>
             </a:lvl4pPr>
             <a:lvl5pPr marL="0" indent="0">
               <a:lnSpc>
@@ -1448,6 +1479,7 @@
                 <a:spcPts val="0"/>
               </a:spcAft>
               <a:buNone/>
+              <a:defRPr/>
             </a:lvl5pPr>
             <a:lvl6pPr marL="0" indent="0">
               <a:lnSpc>
@@ -1460,6 +1492,7 @@
                 <a:spcPts val="0"/>
               </a:spcAft>
               <a:buNone/>
+              <a:defRPr/>
             </a:lvl6pPr>
             <a:lvl7pPr marL="0" indent="0">
               <a:lnSpc>
@@ -1472,6 +1505,7 @@
                 <a:spcPts val="0"/>
               </a:spcAft>
               <a:buNone/>
+              <a:defRPr/>
             </a:lvl7pPr>
             <a:lvl8pPr marL="0" indent="0">
               <a:lnSpc>
@@ -1484,6 +1518,7 @@
                 <a:spcPts val="0"/>
               </a:spcAft>
               <a:buNone/>
+              <a:defRPr/>
             </a:lvl8pPr>
             <a:lvl9pPr marL="0" indent="0">
               <a:lnSpc>
@@ -1496,6 +1531,7 @@
                 <a:spcPts val="0"/>
               </a:spcAft>
               <a:buNone/>
+              <a:defRPr/>
             </a:lvl9pPr>
           </a:lstStyle>
           <a:p xmlns:a="http://schemas.openxmlformats.org/drawingml/2006/main"/>
@@ -1557,6 +1593,7 @@
                 <a:spcPts val="1200"/>
               </a:spcAft>
               <a:buChar char="•"/>
+              <a:defRPr/>
             </a:lvl1pPr>
             <a:lvl2pPr marL="533400" indent="-228600">
               <a:lnSpc>
@@ -1569,6 +1606,7 @@
                 <a:spcPts val="1200"/>
               </a:spcAft>
               <a:buChar char="•"/>
+              <a:defRPr/>
             </a:lvl2pPr>
             <a:lvl3pPr marL="838200" indent="-228600">
               <a:lnSpc>
@@ -1581,6 +1619,7 @@
                 <a:spcPts val="1200"/>
               </a:spcAft>
               <a:buChar char="•"/>
+              <a:defRPr/>
             </a:lvl3pPr>
             <a:lvl4pPr marL="1143000" indent="-228600">
               <a:lnSpc>
@@ -1593,6 +1632,7 @@
                 <a:spcPts val="1200"/>
               </a:spcAft>
               <a:buChar char="•"/>
+              <a:defRPr/>
             </a:lvl4pPr>
             <a:lvl5pPr marL="1447800" indent="-228600">
               <a:lnSpc>
@@ -1605,6 +1645,7 @@
                 <a:spcPts val="1200"/>
               </a:spcAft>
               <a:buChar char="•"/>
+              <a:defRPr/>
             </a:lvl5pPr>
             <a:lvl6pPr marL="1752600" indent="-228600">
               <a:lnSpc>
@@ -1617,6 +1658,7 @@
                 <a:spcPts val="1200"/>
               </a:spcAft>
               <a:buChar char="•"/>
+              <a:defRPr/>
             </a:lvl6pPr>
             <a:lvl7pPr marL="2057400" indent="-228600">
               <a:lnSpc>
@@ -1629,6 +1671,7 @@
                 <a:spcPts val="1200"/>
               </a:spcAft>
               <a:buChar char="•"/>
+              <a:defRPr/>
             </a:lvl7pPr>
             <a:lvl8pPr marL="2362200" indent="-228600">
               <a:lnSpc>
@@ -1641,6 +1684,7 @@
                 <a:spcPts val="1200"/>
               </a:spcAft>
               <a:buChar char="•"/>
+              <a:defRPr/>
             </a:lvl8pPr>
             <a:lvl9pPr marL="2667000" indent="-228600">
               <a:lnSpc>
@@ -1653,6 +1697,7 @@
                 <a:spcPts val="1200"/>
               </a:spcAft>
               <a:buChar char="•"/>
+              <a:defRPr/>
             </a:lvl9pPr>
           </a:lstStyle>
           <a:p xmlns:a="http://schemas.openxmlformats.org/drawingml/2006/main"/>
@@ -1731,6 +1776,7 @@
                 <a:spcPts val="0"/>
               </a:spcAft>
               <a:buNone/>
+              <a:defRPr/>
             </a:lvl1pPr>
             <a:lvl2pPr marL="0" indent="0">
               <a:lnSpc>
@@ -1743,6 +1789,7 @@
                 <a:spcPts val="0"/>
               </a:spcAft>
               <a:buNone/>
+              <a:defRPr/>
             </a:lvl2pPr>
             <a:lvl3pPr marL="0" indent="0">
               <a:lnSpc>
@@ -1755,6 +1802,7 @@
                 <a:spcPts val="0"/>
               </a:spcAft>
               <a:buNone/>
+              <a:defRPr/>
             </a:lvl3pPr>
             <a:lvl4pPr marL="0" indent="0">
               <a:lnSpc>
@@ -1767,6 +1815,7 @@
                 <a:spcPts val="0"/>
               </a:spcAft>
               <a:buNone/>
+              <a:defRPr/>
             </a:lvl4pPr>
             <a:lvl5pPr marL="0" indent="0">
               <a:lnSpc>
@@ -1779,6 +1828,7 @@
                 <a:spcPts val="0"/>
               </a:spcAft>
               <a:buNone/>
+              <a:defRPr/>
             </a:lvl5pPr>
             <a:lvl6pPr marL="0" indent="0">
               <a:lnSpc>
@@ -1791,6 +1841,7 @@
                 <a:spcPts val="0"/>
               </a:spcAft>
               <a:buNone/>
+              <a:defRPr/>
             </a:lvl6pPr>
             <a:lvl7pPr marL="0" indent="0">
               <a:lnSpc>
@@ -1803,6 +1854,7 @@
                 <a:spcPts val="0"/>
               </a:spcAft>
               <a:buNone/>
+              <a:defRPr/>
             </a:lvl7pPr>
             <a:lvl8pPr marL="0" indent="0">
               <a:lnSpc>
@@ -1815,6 +1867,7 @@
                 <a:spcPts val="0"/>
               </a:spcAft>
               <a:buNone/>
+              <a:defRPr/>
             </a:lvl8pPr>
             <a:lvl9pPr marL="0" indent="0">
               <a:lnSpc>
@@ -1827,6 +1880,7 @@
                 <a:spcPts val="0"/>
               </a:spcAft>
               <a:buNone/>
+              <a:defRPr/>
             </a:lvl9pPr>
           </a:lstStyle>
           <a:p xmlns:a="http://schemas.openxmlformats.org/drawingml/2006/main"/>
@@ -1888,6 +1942,7 @@
                 <a:spcPts val="1200"/>
               </a:spcAft>
               <a:buChar char="•"/>
+              <a:defRPr/>
             </a:lvl1pPr>
             <a:lvl2pPr marL="533400" indent="-228600">
               <a:lnSpc>
@@ -1900,6 +1955,7 @@
                 <a:spcPts val="1200"/>
               </a:spcAft>
               <a:buChar char="•"/>
+              <a:defRPr/>
             </a:lvl2pPr>
             <a:lvl3pPr marL="838200" indent="-228600">
               <a:lnSpc>
@@ -1912,6 +1968,7 @@
                 <a:spcPts val="1200"/>
               </a:spcAft>
               <a:buChar char="•"/>
+              <a:defRPr/>
             </a:lvl3pPr>
             <a:lvl4pPr marL="1143000" indent="-228600">
               <a:lnSpc>
@@ -1924,6 +1981,7 @@
                 <a:spcPts val="1200"/>
               </a:spcAft>
               <a:buChar char="•"/>
+              <a:defRPr/>
             </a:lvl4pPr>
             <a:lvl5pPr marL="1447800" indent="-228600">
               <a:lnSpc>
@@ -1936,6 +1994,7 @@
                 <a:spcPts val="1200"/>
               </a:spcAft>
               <a:buChar char="•"/>
+              <a:defRPr/>
             </a:lvl5pPr>
             <a:lvl6pPr marL="1752600" indent="-228600">
               <a:lnSpc>
@@ -1948,6 +2007,7 @@
                 <a:spcPts val="1200"/>
               </a:spcAft>
               <a:buChar char="•"/>
+              <a:defRPr/>
             </a:lvl6pPr>
             <a:lvl7pPr marL="2057400" indent="-228600">
               <a:lnSpc>
@@ -1960,6 +2020,7 @@
                 <a:spcPts val="1200"/>
               </a:spcAft>
               <a:buChar char="•"/>
+              <a:defRPr/>
             </a:lvl7pPr>
             <a:lvl8pPr marL="2362200" indent="-228600">
               <a:lnSpc>
@@ -1972,6 +2033,7 @@
                 <a:spcPts val="1200"/>
               </a:spcAft>
               <a:buChar char="•"/>
+              <a:defRPr/>
             </a:lvl8pPr>
             <a:lvl9pPr marL="2667000" indent="-228600">
               <a:lnSpc>
@@ -1984,6 +2046,7 @@
                 <a:spcPts val="1200"/>
               </a:spcAft>
               <a:buChar char="•"/>
+              <a:defRPr/>
             </a:lvl9pPr>
           </a:lstStyle>
           <a:p xmlns:a="http://schemas.openxmlformats.org/drawingml/2006/main"/>
@@ -2045,6 +2108,7 @@
                 <a:spcPts val="1200"/>
               </a:spcAft>
               <a:buChar char="•"/>
+              <a:defRPr/>
             </a:lvl1pPr>
             <a:lvl2pPr marL="533400" indent="-228600">
               <a:lnSpc>
@@ -2057,6 +2121,7 @@
                 <a:spcPts val="1200"/>
               </a:spcAft>
               <a:buChar char="•"/>
+              <a:defRPr/>
             </a:lvl2pPr>
             <a:lvl3pPr marL="838200" indent="-228600">
               <a:lnSpc>
@@ -2069,6 +2134,7 @@
                 <a:spcPts val="1200"/>
               </a:spcAft>
               <a:buChar char="•"/>
+              <a:defRPr/>
             </a:lvl3pPr>
             <a:lvl4pPr marL="1143000" indent="-228600">
               <a:lnSpc>
@@ -2081,6 +2147,7 @@
                 <a:spcPts val="1200"/>
               </a:spcAft>
               <a:buChar char="•"/>
+              <a:defRPr/>
             </a:lvl4pPr>
             <a:lvl5pPr marL="1447800" indent="-228600">
               <a:lnSpc>
@@ -2093,6 +2160,7 @@
                 <a:spcPts val="1200"/>
               </a:spcAft>
               <a:buChar char="•"/>
+              <a:defRPr/>
             </a:lvl5pPr>
             <a:lvl6pPr marL="1752600" indent="-228600">
               <a:lnSpc>
@@ -2105,6 +2173,7 @@
                 <a:spcPts val="1200"/>
               </a:spcAft>
               <a:buChar char="•"/>
+              <a:defRPr/>
             </a:lvl6pPr>
             <a:lvl7pPr marL="2057400" indent="-228600">
               <a:lnSpc>
@@ -2117,6 +2186,7 @@
                 <a:spcPts val="1200"/>
               </a:spcAft>
               <a:buChar char="•"/>
+              <a:defRPr/>
             </a:lvl7pPr>
             <a:lvl8pPr marL="2362200" indent="-228600">
               <a:lnSpc>
@@ -2129,6 +2199,7 @@
                 <a:spcPts val="1200"/>
               </a:spcAft>
               <a:buChar char="•"/>
+              <a:defRPr/>
             </a:lvl8pPr>
             <a:lvl9pPr marL="2667000" indent="-228600">
               <a:lnSpc>
@@ -2141,6 +2212,7 @@
                 <a:spcPts val="1200"/>
               </a:spcAft>
               <a:buChar char="•"/>
+              <a:defRPr/>
             </a:lvl9pPr>
           </a:lstStyle>
           <a:p xmlns:a="http://schemas.openxmlformats.org/drawingml/2006/main"/>
@@ -2219,6 +2291,7 @@
                 <a:spcPts val="0"/>
               </a:spcAft>
               <a:buNone/>
+              <a:defRPr/>
             </a:lvl1pPr>
             <a:lvl2pPr marL="0" indent="0">
               <a:lnSpc>
@@ -2231,6 +2304,7 @@
                 <a:spcPts val="0"/>
               </a:spcAft>
               <a:buNone/>
+              <a:defRPr/>
             </a:lvl2pPr>
             <a:lvl3pPr marL="0" indent="0">
               <a:lnSpc>
@@ -2243,6 +2317,7 @@
                 <a:spcPts val="0"/>
               </a:spcAft>
               <a:buNone/>
+              <a:defRPr/>
             </a:lvl3pPr>
             <a:lvl4pPr marL="0" indent="0">
               <a:lnSpc>
@@ -2255,6 +2330,7 @@
                 <a:spcPts val="0"/>
               </a:spcAft>
               <a:buNone/>
+              <a:defRPr/>
             </a:lvl4pPr>
             <a:lvl5pPr marL="0" indent="0">
               <a:lnSpc>
@@ -2267,6 +2343,7 @@
                 <a:spcPts val="0"/>
               </a:spcAft>
               <a:buNone/>
+              <a:defRPr/>
             </a:lvl5pPr>
             <a:lvl6pPr marL="0" indent="0">
               <a:lnSpc>
@@ -2279,6 +2356,7 @@
                 <a:spcPts val="0"/>
               </a:spcAft>
               <a:buNone/>
+              <a:defRPr/>
             </a:lvl6pPr>
             <a:lvl7pPr marL="0" indent="0">
               <a:lnSpc>
@@ -2291,6 +2369,7 @@
                 <a:spcPts val="0"/>
               </a:spcAft>
               <a:buNone/>
+              <a:defRPr/>
             </a:lvl7pPr>
             <a:lvl8pPr marL="0" indent="0">
               <a:lnSpc>
@@ -2303,6 +2382,7 @@
                 <a:spcPts val="0"/>
               </a:spcAft>
               <a:buNone/>
+              <a:defRPr/>
             </a:lvl8pPr>
             <a:lvl9pPr marL="0" indent="0">
               <a:lnSpc>
@@ -2315,6 +2395,7 @@
                 <a:spcPts val="0"/>
               </a:spcAft>
               <a:buNone/>
+              <a:defRPr/>
             </a:lvl9pPr>
           </a:lstStyle>
           <a:p xmlns:a="http://schemas.openxmlformats.org/drawingml/2006/main"/>
@@ -2376,6 +2457,7 @@
                 <a:spcPts val="1200"/>
               </a:spcAft>
               <a:buChar char="•"/>
+              <a:defRPr/>
             </a:lvl1pPr>
             <a:lvl2pPr marL="533400" indent="-228600">
               <a:lnSpc>
@@ -2388,6 +2470,7 @@
                 <a:spcPts val="1200"/>
               </a:spcAft>
               <a:buChar char="•"/>
+              <a:defRPr/>
             </a:lvl2pPr>
             <a:lvl3pPr marL="838200" indent="-228600">
               <a:lnSpc>
@@ -2400,6 +2483,7 @@
                 <a:spcPts val="1200"/>
               </a:spcAft>
               <a:buChar char="•"/>
+              <a:defRPr/>
             </a:lvl3pPr>
             <a:lvl4pPr marL="1143000" indent="-228600">
               <a:lnSpc>
@@ -2412,6 +2496,7 @@
                 <a:spcPts val="1200"/>
               </a:spcAft>
               <a:buChar char="•"/>
+              <a:defRPr/>
             </a:lvl4pPr>
             <a:lvl5pPr marL="1447800" indent="-228600">
               <a:lnSpc>
@@ -2424,6 +2509,7 @@
                 <a:spcPts val="1200"/>
               </a:spcAft>
               <a:buChar char="•"/>
+              <a:defRPr/>
             </a:lvl5pPr>
             <a:lvl6pPr marL="1752600" indent="-228600">
               <a:lnSpc>
@@ -2436,6 +2522,7 @@
                 <a:spcPts val="1200"/>
               </a:spcAft>
               <a:buChar char="•"/>
+              <a:defRPr/>
             </a:lvl6pPr>
             <a:lvl7pPr marL="2057400" indent="-228600">
               <a:lnSpc>
@@ -2448,6 +2535,7 @@
                 <a:spcPts val="1200"/>
               </a:spcAft>
               <a:buChar char="•"/>
+              <a:defRPr/>
             </a:lvl7pPr>
             <a:lvl8pPr marL="2362200" indent="-228600">
               <a:lnSpc>
@@ -2460,6 +2548,7 @@
                 <a:spcPts val="1200"/>
               </a:spcAft>
               <a:buChar char="•"/>
+              <a:defRPr/>
             </a:lvl8pPr>
             <a:lvl9pPr marL="2667000" indent="-228600">
               <a:lnSpc>
@@ -2472,6 +2561,7 @@
                 <a:spcPts val="1200"/>
               </a:spcAft>
               <a:buChar char="•"/>
+              <a:defRPr/>
             </a:lvl9pPr>
           </a:lstStyle>
           <a:p xmlns:a="http://schemas.openxmlformats.org/drawingml/2006/main"/>
@@ -2520,12 +2610,12 @@
   </p:cSld>
   <p:clrMap bg1="lt1" tx1="dk1" bg2="lt2" tx2="dk2" accent1="accent1" accent2="accent2" accent3="accent3" accent4="accent4" accent5="accent5" accent6="accent6" hlink="hlink" folHlink="folHlink"/>
   <p:sldLayoutIdLst>
-    <p:sldLayoutId xmlns:r="http://schemas.openxmlformats.org/officeDocument/2006/relationships" id="2147483649" r:id="Ref9bdce046764bc8"/>
-    <p:sldLayoutId xmlns:r="http://schemas.openxmlformats.org/officeDocument/2006/relationships" id="2147483650" r:id="Re7cc79ebec1f46f8"/>
-    <p:sldLayoutId xmlns:r="http://schemas.openxmlformats.org/officeDocument/2006/relationships" id="2147483651" r:id="R77eec236fdef4b57"/>
-    <p:sldLayoutId xmlns:r="http://schemas.openxmlformats.org/officeDocument/2006/relationships" id="2147483652" r:id="R37c47147090940d1"/>
-    <p:sldLayoutId xmlns:r="http://schemas.openxmlformats.org/officeDocument/2006/relationships" id="2147483653" r:id="Rf7a5ebb5ddaf4c01"/>
-    <p:sldLayoutId xmlns:r="http://schemas.openxmlformats.org/officeDocument/2006/relationships" id="2147483654" r:id="Rc7ef5442b1a44f71"/>
+    <p:sldLayoutId xmlns:r="http://schemas.openxmlformats.org/officeDocument/2006/relationships" id="2147483649" r:id="R993532a9007f44c7"/>
+    <p:sldLayoutId xmlns:r="http://schemas.openxmlformats.org/officeDocument/2006/relationships" id="2147483650" r:id="Re688709a69b64fbd"/>
+    <p:sldLayoutId xmlns:r="http://schemas.openxmlformats.org/officeDocument/2006/relationships" id="2147483651" r:id="R2822ccc6d7c24be8"/>
+    <p:sldLayoutId xmlns:r="http://schemas.openxmlformats.org/officeDocument/2006/relationships" id="2147483652" r:id="Rd2cd99ed7d93425a"/>
+    <p:sldLayoutId xmlns:r="http://schemas.openxmlformats.org/officeDocument/2006/relationships" id="2147483653" r:id="R69284aabbb0d462b"/>
+    <p:sldLayoutId xmlns:r="http://schemas.openxmlformats.org/officeDocument/2006/relationships" id="2147483654" r:id="Rd08051ae803547e4"/>
   </p:sldLayoutIdLst>
   <p:txStyles>
     <p:titleStyle>
@@ -4840,7 +4930,7 @@
           <p:cNvPr id="4" name="">
             <a:extLst xmlns:a="http://schemas.openxmlformats.org/drawingml/2006/main">
               <a:ext uri="{FF2B5EF4-FFF2-40B4-BE49-F238E27FC236}">
-                <a16:creationId xmlns:a16="http://schemas.microsoft.com/office/drawing/2014/main" id="{BAECFC34-8921-4414-8A45-0E460F25C256}"/>
+                <a16:creationId xmlns:a16="http://schemas.microsoft.com/office/drawing/2014/main" id="{B384DAA3-3A74-4A16-AC36-2818B7FB75DF}"/>
               </a:ext>
             </a:extLst>
           </p:cNvPr>
@@ -4850,7 +4940,7 @@
           <p:nvPr/>
         </p:nvPicPr>
         <p:blipFill>
-          <a:blip xmlns:r="http://schemas.openxmlformats.org/officeDocument/2006/relationships" xmlns:a="http://schemas.openxmlformats.org/drawingml/2006/main" r:embed="R48dc944fd0ab412a"/>
+          <a:blip xmlns:r="http://schemas.openxmlformats.org/officeDocument/2006/relationships" xmlns:a="http://schemas.openxmlformats.org/drawingml/2006/main" r:embed="R1f9f95b6227742de"/>
           <a:stretch xmlns:a="http://schemas.openxmlformats.org/drawingml/2006/main"/>
         </p:blipFill>
         <p:spPr>
@@ -5085,7 +5175,7 @@
                 <a:ea typeface="Arial"/>
                 <a:cs typeface="Arial"/>
               </a:rPr>
-              <a:t>Actual Operator capture, 15 Oct 2026</a:t>
+              <a:t>Actual Operator capture, 18 Oct 2026</a:t>
             </a:r>
           </a:p>
           <a:p xmlns:a="http://schemas.openxmlformats.org/drawingml/2006/main">
@@ -5112,7 +5202,7 @@
                 <a:ea typeface="Arial"/>
                 <a:cs typeface="Arial"/>
               </a:rPr>
-              <a:t>Six synthetic incidents and resources shown.</a:t>
+              <a:t>Dashboard: 12 active reports; 8 critical.</a:t>
             </a:r>
           </a:p>
           <a:p xmlns:a="http://schemas.openxmlformats.org/drawingml/2006/main">
@@ -5139,7 +5229,7 @@
                 <a:ea typeface="Arial"/>
                 <a:cs typeface="Arial"/>
               </a:rPr>
-              <a:t>Capture predates later UI polish. Attribution is partly clipped. Current final-state capture pending.</a:t>
+              <a:t>Desktop capture only. Dataset and source revision were not supplied.</a:t>
             </a:r>
           </a:p>
         </p:txBody>
@@ -5178,7 +5268,7 @@
           <p:cNvPr id="18" name="">
             <a:extLst xmlns:a="http://schemas.openxmlformats.org/drawingml/2006/main">
               <a:ext uri="{FF2B5EF4-FFF2-40B4-BE49-F238E27FC236}">
-                <a16:creationId xmlns:a16="http://schemas.microsoft.com/office/drawing/2014/main" id="{9A84ED49-FDC6-48DA-8DB8-AD00548A2918}"/>
+                <a16:creationId xmlns:a16="http://schemas.microsoft.com/office/drawing/2014/main" id="{1567AC48-0E7C-4696-80FF-AE023C8C0135}"/>
               </a:ext>
             </a:extLst>
           </p:cNvPr>
@@ -5210,7 +5300,7 @@
           <p:cNvPr id="17" name="">
             <a:extLst xmlns:a="http://schemas.openxmlformats.org/drawingml/2006/main">
               <a:ext uri="{FF2B5EF4-FFF2-40B4-BE49-F238E27FC236}">
-                <a16:creationId xmlns:a16="http://schemas.microsoft.com/office/drawing/2014/main" id="{50A31AE3-5D86-4F90-8D32-C60A9441A6F0}"/>
+                <a16:creationId xmlns:a16="http://schemas.microsoft.com/office/drawing/2014/main" id="{D52FA32C-1DC5-46B6-AF1E-EF99FF72FB6E}"/>
               </a:ext>
             </a:extLst>
           </p:cNvPr>
@@ -5242,7 +5332,7 @@
           <p:cNvPr id="16" name="">
             <a:extLst xmlns:a="http://schemas.openxmlformats.org/drawingml/2006/main">
               <a:ext uri="{FF2B5EF4-FFF2-40B4-BE49-F238E27FC236}">
-                <a16:creationId xmlns:a16="http://schemas.microsoft.com/office/drawing/2014/main" id="{1BE93D0E-632C-467C-BBD7-F43DCF9E2ECF}"/>
+                <a16:creationId xmlns:a16="http://schemas.microsoft.com/office/drawing/2014/main" id="{002EAC77-BADD-41BB-85C8-B50893DC191D}"/>
               </a:ext>
             </a:extLst>
           </p:cNvPr>
@@ -5274,7 +5364,7 @@
           <p:cNvPr id="15" name="">
             <a:extLst xmlns:a="http://schemas.openxmlformats.org/drawingml/2006/main">
               <a:ext uri="{FF2B5EF4-FFF2-40B4-BE49-F238E27FC236}">
-                <a16:creationId xmlns:a16="http://schemas.microsoft.com/office/drawing/2014/main" id="{49ABB9DD-1015-438D-8C5A-81DE10EBD4C5}"/>
+                <a16:creationId xmlns:a16="http://schemas.microsoft.com/office/drawing/2014/main" id="{D8676072-5636-4025-B5C2-23BD120BFC2C}"/>
               </a:ext>
             </a:extLst>
           </p:cNvPr>
@@ -5306,7 +5396,7 @@
           <p:cNvPr id="14" name="">
             <a:extLst xmlns:a="http://schemas.openxmlformats.org/drawingml/2006/main">
               <a:ext uri="{FF2B5EF4-FFF2-40B4-BE49-F238E27FC236}">
-                <a16:creationId xmlns:a16="http://schemas.microsoft.com/office/drawing/2014/main" id="{B8421946-9122-49E9-8613-25E1A4E5948D}"/>
+                <a16:creationId xmlns:a16="http://schemas.microsoft.com/office/drawing/2014/main" id="{ACB36949-ABB9-4FEC-BEC1-BA0FBC51F762}"/>
               </a:ext>
             </a:extLst>
           </p:cNvPr>
@@ -5338,7 +5428,7 @@
           <p:cNvPr id="13" name="">
             <a:extLst xmlns:a="http://schemas.openxmlformats.org/drawingml/2006/main">
               <a:ext uri="{FF2B5EF4-FFF2-40B4-BE49-F238E27FC236}">
-                <a16:creationId xmlns:a16="http://schemas.microsoft.com/office/drawing/2014/main" id="{F71CF957-6B69-4E8A-A0E8-17D4BC9FF895}"/>
+                <a16:creationId xmlns:a16="http://schemas.microsoft.com/office/drawing/2014/main" id="{32D94674-51ED-43B1-8F68-975EE5F8EBCD}"/>
               </a:ext>
             </a:extLst>
           </p:cNvPr>
@@ -5370,7 +5460,7 @@
           <p:cNvPr id="12" name="">
             <a:extLst xmlns:a="http://schemas.openxmlformats.org/drawingml/2006/main">
               <a:ext uri="{FF2B5EF4-FFF2-40B4-BE49-F238E27FC236}">
-                <a16:creationId xmlns:a16="http://schemas.microsoft.com/office/drawing/2014/main" id="{8655936A-D005-4E22-BAC6-577A822358C9}"/>
+                <a16:creationId xmlns:a16="http://schemas.microsoft.com/office/drawing/2014/main" id="{B99E30B7-BA5C-47AE-BF50-78F5AC6C30F7}"/>
               </a:ext>
             </a:extLst>
           </p:cNvPr>
@@ -5666,6 +5756,7 @@
           </a:lstStyle>
           <a:p xmlns:a="http://schemas.openxmlformats.org/drawingml/2006/main">
             <a:pPr algn="ctr">
+              <a:buNone/>
               <a:defRPr sz="1575" b="1">
                 <a:solidFill>
                   <a:srgbClr val="172B3A"/>
@@ -5689,6 +5780,7 @@
           </a:p>
           <a:p xmlns:a="http://schemas.openxmlformats.org/drawingml/2006/main">
             <a:pPr algn="ctr">
+              <a:buNone/>
               <a:defRPr sz="1575" b="1">
                 <a:solidFill>
                   <a:srgbClr val="172B3A"/>
@@ -5762,6 +5854,7 @@
           </a:lstStyle>
           <a:p xmlns:a="http://schemas.openxmlformats.org/drawingml/2006/main">
             <a:pPr algn="ctr">
+              <a:buNone/>
               <a:defRPr sz="1575" b="1">
                 <a:solidFill>
                   <a:srgbClr val="172B3A"/>
@@ -5785,6 +5878,7 @@
           </a:p>
           <a:p xmlns:a="http://schemas.openxmlformats.org/drawingml/2006/main">
             <a:pPr algn="ctr">
+              <a:buNone/>
               <a:defRPr sz="1575" b="1">
                 <a:solidFill>
                   <a:srgbClr val="172B3A"/>
@@ -5858,6 +5952,7 @@
           </a:lstStyle>
           <a:p xmlns:a="http://schemas.openxmlformats.org/drawingml/2006/main">
             <a:pPr algn="ctr">
+              <a:buNone/>
               <a:defRPr sz="1575" b="1">
                 <a:solidFill>
                   <a:srgbClr val="172B3A"/>
@@ -5881,6 +5976,7 @@
           </a:p>
           <a:p xmlns:a="http://schemas.openxmlformats.org/drawingml/2006/main">
             <a:pPr algn="ctr">
+              <a:buNone/>
               <a:defRPr sz="1575" b="1">
                 <a:solidFill>
                   <a:srgbClr val="172B3A"/>
@@ -5954,6 +6050,7 @@
           </a:lstStyle>
           <a:p xmlns:a="http://schemas.openxmlformats.org/drawingml/2006/main">
             <a:pPr algn="ctr">
+              <a:buNone/>
               <a:defRPr sz="1575" b="1">
                 <a:solidFill>
                   <a:srgbClr val="172B3A"/>
@@ -5977,6 +6074,7 @@
           </a:p>
           <a:p xmlns:a="http://schemas.openxmlformats.org/drawingml/2006/main">
             <a:pPr algn="ctr">
+              <a:buNone/>
               <a:defRPr sz="1575" b="1">
                 <a:solidFill>
                   <a:srgbClr val="172B3A"/>
@@ -6050,6 +6148,7 @@
           </a:lstStyle>
           <a:p xmlns:a="http://schemas.openxmlformats.org/drawingml/2006/main">
             <a:pPr algn="ctr">
+              <a:buNone/>
               <a:defRPr sz="1575" b="1">
                 <a:solidFill>
                   <a:srgbClr val="172B3A"/>
@@ -6073,6 +6172,7 @@
           </a:p>
           <a:p xmlns:a="http://schemas.openxmlformats.org/drawingml/2006/main">
             <a:pPr algn="ctr">
+              <a:buNone/>
               <a:defRPr sz="1575" b="1">
                 <a:solidFill>
                   <a:srgbClr val="172B3A"/>
@@ -6146,6 +6246,7 @@
           </a:lstStyle>
           <a:p xmlns:a="http://schemas.openxmlformats.org/drawingml/2006/main">
             <a:pPr algn="ctr">
+              <a:buNone/>
               <a:defRPr sz="1575" b="1">
                 <a:solidFill>
                   <a:srgbClr val="172B3A"/>
@@ -6219,6 +6320,7 @@
           </a:lstStyle>
           <a:p xmlns:a="http://schemas.openxmlformats.org/drawingml/2006/main">
             <a:pPr algn="ctr">
+              <a:buNone/>
               <a:defRPr sz="1575" b="1">
                 <a:solidFill>
                   <a:srgbClr val="172B3A"/>
@@ -6242,6 +6344,7 @@
           </a:p>
           <a:p xmlns:a="http://schemas.openxmlformats.org/drawingml/2006/main">
             <a:pPr algn="ctr">
+              <a:buNone/>
               <a:defRPr sz="1575" b="1">
                 <a:solidFill>
                   <a:srgbClr val="172B3A"/>
@@ -6315,6 +6418,7 @@
           </a:lstStyle>
           <a:p xmlns:a="http://schemas.openxmlformats.org/drawingml/2006/main">
             <a:pPr algn="ctr">
+              <a:buNone/>
               <a:defRPr sz="1575" b="1">
                 <a:solidFill>
                   <a:srgbClr val="172B3A"/>
@@ -6338,6 +6442,7 @@
           </a:p>
           <a:p xmlns:a="http://schemas.openxmlformats.org/drawingml/2006/main">
             <a:pPr algn="ctr">
+              <a:buNone/>
               <a:defRPr sz="1575" b="1">
                 <a:solidFill>
                   <a:srgbClr val="172B3A"/>
@@ -7272,7 +7377,7 @@
                 <a:ea typeface="Arial"/>
                 <a:cs typeface="Arial"/>
               </a:rPr>
-              <a:t>Local release-preparation checks, 17 Oct 2026</a:t>
+              <a:t>Dated baseline checks, 17 Oct 2026</a:t>
             </a:r>
           </a:p>
         </p:txBody>
@@ -7345,7 +7450,7 @@
                 <a:ea typeface="Arial"/>
                 <a:cs typeface="Arial"/>
               </a:rPr>
-              <a:t>Release build passed (49 warnings, 0 errors)</a:t>
+              <a:t>Release build passed before later C# edits</a:t>
             </a:r>
           </a:p>
           <a:p xmlns:a="http://schemas.openxmlformats.org/drawingml/2006/main">
@@ -7372,7 +7477,7 @@
                 <a:ea typeface="Arial"/>
                 <a:cs typeface="Arial"/>
               </a:rPr>
-              <a:t>572 unit tests, 89 isolated SQL integration tests</a:t>
+              <a:t>Baseline: 572 unit, 89 SQL tests passed</a:t>
             </a:r>
           </a:p>
           <a:p xmlns:a="http://schemas.openxmlformats.org/drawingml/2006/main">
@@ -7399,7 +7504,7 @@
                 <a:ea typeface="Arial"/>
                 <a:cs typeface="Arial"/>
               </a:rPr>
-              <a:t>28 UI JavaScript checks, 4 JavaScript syntax checks</a:t>
+              <a:t>28 UI and 4 JavaScript syntax checks passed</a:t>
             </a:r>
           </a:p>
         </p:txBody>
@@ -7499,7 +7604,7 @@
                 <a:ea typeface="Arial"/>
                 <a:cs typeface="Arial"/>
               </a:rPr>
-              <a:t>Current browser and responsive acceptance pending.</a:t>
+              <a:t>Selected desktop views; responsive tests pending.</a:t>
             </a:r>
           </a:p>
           <a:p xmlns:a="http://schemas.openxmlformats.org/drawingml/2006/main">
@@ -7553,7 +7658,7 @@
                 <a:ea typeface="Arial"/>
                 <a:cs typeface="Arial"/>
               </a:rPr>
-              <a:t>Development startup requires reviewed database migrations.</a:t>
+              <a:t>Development startup applies pending migrations.</a:t>
             </a:r>
           </a:p>
         </p:txBody>
@@ -7626,7 +7731,7 @@
                 <a:ea typeface="Arial"/>
                 <a:cs typeface="Arial"/>
               </a:rPr>
-              <a:t>Next: align the local schema, run the real walkthrough, capture corrected screens, and review release blockers.</a:t>
+              <a:t>Resource view still loading; Copilot response absent.</a:t>
             </a:r>
           </a:p>
         </p:txBody>

</xml_diff>